<commit_message>
Atualiza populacao e renda para o Censo 2022 (IBGE, setores censitarios)
</commit_message>
<xml_diff>
--- a/docs/apresentacao_case_fnp.pptx
+++ b/docs/apresentacao_case_fnp.pptx
@@ -119,12 +119,12 @@
   <p:extLst>
     <p:ext uri="{521415D9-36F7-43E2-AB2F-B90AF26B5E84}">
       <p14:sectionLst xmlns:p14="http://schemas.microsoft.com/office/powerpoint/2010/main">
-        <p14:section name="Abertura" id="{a2000209-5ba7-8f30-4205-9774f41540e9}">
+        <p14:section name="Abertura" id="{ce2699ae-a409-62ed-f285-aee57a256f31}">
           <p14:sldIdLst>
             <p14:sldId id="256"/>
           </p14:sldIdLst>
         </p14:section>
-        <p14:section name="Desafio 1 – GTFS em Fortaleza" id="{9b9af760-f3c9-6664-f1a0-321b06de99c5}">
+        <p14:section name="Desafio 1 – GTFS em Fortaleza" id="{7f021e00-cf6d-fba8-e531-21101a69fecb}">
           <p14:sldIdLst>
             <p14:sldId id="257"/>
             <p14:sldId id="258"/>
@@ -136,14 +136,14 @@
             <p14:sldId id="264"/>
           </p14:sldIdLst>
         </p14:section>
-        <p14:section name="Desafio 2 – Apoio ao município" id="{7f0e37b0-4ced-41de-b8d5-3b9a071137bb}">
+        <p14:section name="Desafio 2 – Apoio ao município" id="{a0a9de93-e1bc-68a1-81d6-94950e3a7060}">
           <p14:sldIdLst>
             <p14:sldId id="265"/>
             <p14:sldId id="266"/>
             <p14:sldId id="267"/>
           </p14:sldIdLst>
         </p14:section>
-        <p14:section name="Encerramento" id="{09d644ba-3211-2561-9ef9-3ad8d13bd4dd}">
+        <p14:section name="Encerramento" id="{5d47d9f9-84c5-2f9a-8b6d-c4a23c62d7a1}">
           <p14:sldIdLst>
             <p14:sldId id="268"/>
           </p14:sldIdLst>
@@ -2357,7 +2357,7 @@
                 </a:solidFill>
                 <a:latin typeface="+mn-lt"/>
               </a:rPr>
-              <a:t>Por quintil de renda per capita (%)</a:t>
+              <a:t>Por quintil de renda do responsável pelo domicílio (%)</a:t>
             </a:r>
           </a:p>
         </c:rich>
@@ -2449,19 +2449,19 @@
                 <c:formatCode>General</c:formatCode>
                 <c:ptCount val="5"/>
                 <c:pt idx="0">
-                  <c:v>72.9</c:v>
+                  <c:v>71.6</c:v>
                 </c:pt>
                 <c:pt idx="1">
-                  <c:v>77.7</c:v>
+                  <c:v>78.2</c:v>
                 </c:pt>
                 <c:pt idx="2">
-                  <c:v>80.4</c:v>
+                  <c:v>72.6</c:v>
                 </c:pt>
                 <c:pt idx="3">
-                  <c:v>78.7</c:v>
+                  <c:v>77.8</c:v>
                 </c:pt>
                 <c:pt idx="4">
-                  <c:v>87.7</c:v>
+                  <c:v>84</c:v>
                 </c:pt>
               </c:numCache>
             </c:numRef>
@@ -2544,19 +2544,19 @@
                 <c:formatCode>General</c:formatCode>
                 <c:ptCount val="5"/>
                 <c:pt idx="0">
-                  <c:v>28.3</c:v>
+                  <c:v>29.8</c:v>
                 </c:pt>
                 <c:pt idx="1">
-                  <c:v>40</c:v>
+                  <c:v>38.7</c:v>
                 </c:pt>
                 <c:pt idx="2">
-                  <c:v>48.2</c:v>
+                  <c:v>44</c:v>
                 </c:pt>
                 <c:pt idx="3">
-                  <c:v>56.5</c:v>
+                  <c:v>54.2</c:v>
                 </c:pt>
                 <c:pt idx="4">
-                  <c:v>70.9</c:v>
+                  <c:v>67.5</c:v>
                 </c:pt>
               </c:numCache>
             </c:numRef>
@@ -3463,7 +3463,7 @@
           <a:p>
             <a:r>
               <a:rPr lang="en-US" dirty="0"/>
-              <a:t>[~25 s] Para fechar: o GTFS transforma a rede em informação para decidir, e em Fortaleza mostrou que um em cada cinco moradores não tem ônibus frequente perto de casa e que os mais pobres alcançam bem menos empregos. Esse valor depende de qualidade e atualização. E a FNP pode encurtar o caminho dos municípios com etapas claras, ferramentas simples e rotina de manutenção. O código está aberto no GitHub, no link do slide. Obrigada, fico à disposição para perguntas.</a:t>
+              <a:t>[~25 s] Para fechar: o GTFS transforma a rede em informação para decidir, e em Fortaleza mostrou que quase um em cada quatro moradores não tem ônibus frequente perto de casa e que os mais pobres alcançam bem menos empregos. Esse valor depende de qualidade e atualização. E a FNP pode encurtar o caminho dos municípios com etapas claras, ferramentas simples e rotina de manutenção. O código está aberto no GitHub, no link do slide. Obrigada, fico à disposição para perguntas.</a:t>
             </a:r>
             <a:endParaRPr lang="en-US" dirty="0"/>
           </a:p>
@@ -3639,7 +3639,7 @@
           <a:p>
             <a:r>
               <a:rPr lang="en-US" dirty="0"/>
-              <a:t>[~30 s] Usei o GTFS do case e cruzei com o projeto Acesso a Oportunidades do IPEA: população e renda por hexágono, empregos formais e o tempo de ônibus até eles. Tudo em R, com código aberto no GitHub. Algumas escolhas: como o arquivo recebido não tem viagens de dia útil, usei o sábado como referência; o pico é de 6h a 8h; cobertura é morar a até 500 metros de uma parada. As limitações principais estão à direita: população de 2010, distância em linha reta e o fato de o GTFS mostrar a oferta programada, não a realizada.</a:t>
+              <a:t>[~30 s] Usei o GTFS do case e cruzei com duas fontes: o Censo 2022 do IBGE, com população e renda por setor censitário, e o projeto Acesso a Oportunidades do IPEA, com empregos formais e o tempo de ônibus até eles. Reparti os setores do Censo nos hexágonos do IPEA, proporcionalmente à área, para cruzar tudo na mesma unidade. Tudo em R, com código aberto no GitHub. Algumas escolhas: como o arquivo recebido não tem viagens de dia útil, usei o sábado como referência; o pico é de 6h a 8h; cobertura é morar a até 500 metros de uma parada. As limitações principais estão à direita: a renda de 2022 é a do responsável pelo domicílio, os dados de empregos e acessibilidade do IPEA são de 2019, a distância é em linha reta e o GTFS mostra a oferta programada, não a realizada.</a:t>
             </a:r>
             <a:endParaRPr lang="en-US" dirty="0"/>
           </a:p>
@@ -3991,7 +3991,7 @@
           <a:p>
             <a:r>
               <a:rPr lang="en-US" dirty="0"/>
-              <a:t>[~40 s] Aqui entra o cruzamento com a população. Quase 100% dos moradores têm uma parada a até 500 metros, então o problema não é falta de ponto. Mas, quando considero só ônibus frequente, a cobertura cai para 80%. Cerca de meio milhão de pessoas, em laranja no mapa, principalmente nas bordas sul e oeste, só contam com linhas de intervalo longo.</a:t>
+              <a:t>[~40 s] Aqui entra o cruzamento com a população. Quase 100% dos moradores têm uma parada a até 500 metros, então o problema não é falta de ponto. Mas, quando considero só ônibus frequente, a cobertura cai para 77%, com a população do Censo 2022. São cerca de 560 mil pessoas, em laranja e vermelho no mapa, principalmente nas bordas sul, oeste e leste, que só contam com linhas de intervalo longo ou não têm parada perto.</a:t>
             </a:r>
             <a:endParaRPr lang="en-US" dirty="0"/>
           </a:p>
@@ -4079,7 +4079,7 @@
           <a:p>
             <a:r>
               <a:rPr lang="en-US" dirty="0"/>
-              <a:t>[~50 s] Este é o cruzamento que mais interessa à gestão. Separando a população em cinco faixas de renda: entre os 20% mais pobres, 73% têm ônibus frequente perto de casa, contra 88% entre os mais ricos. E, usando o indicador do IPEA, os mais pobres alcançam em uma hora de ônibus 28% dos empregos da cidade, contra 71% dos mais ricos, duas vezes e meia mais. O mapa mostra o porquê: os empregos e a oferta se concentram no centro-norte. Com GTFS, a prefeitura consegue medir e acompanhar esse tipo de desigualdade ao mudar a rede. Ressalva: o acesso a empregos foi calculado pelo IPEA com a rede de 2019.</a:t>
+              <a:t>[~50 s] Este é o cruzamento que mais interessa à gestão. Separando a população em cinco faixas de renda: entre os 20% mais pobres, 72% têm ônibus frequente perto de casa, contra 84% entre os mais ricos. E, usando o indicador do IPEA, os mais pobres alcançam em uma hora de ônibus 30% dos empregos da cidade, contra 68% dos mais ricos, mais que o dobro. A cobertura não cai em linha reta (o segundo e o quarto quintis ficam acima do terceiro), mas o contraste entre os extremos é claro. O mapa mostra o porquê: os empregos e a oferta se concentram no centro-norte. Com GTFS, a prefeitura consegue medir e acompanhar esse tipo de desigualdade ao mudar a rede. A renda e a população são do Censo 2022; a ressalva é que o acesso a empregos foi calculado pelo IPEA com a rede de 2019.</a:t>
             </a:r>
             <a:endParaRPr lang="en-US" dirty="0"/>
           </a:p>
@@ -8735,7 +8735,7 @@
                   <a:schemeClr val="bg1"/>
                 </a:solidFill>
               </a:rPr>
-              <a:t>O GTFS mede oferta, frequência, cobertura e equidade. Em Fortaleza, 1 em cada 5 moradores não tem ônibus frequente perto de casa.</a:t>
+              <a:t>O GTFS mede oferta, frequência, cobertura e equidade. Em Fortaleza, quase 1 em cada 4 moradores não tem ônibus frequente perto de casa.</a:t>
             </a:r>
             <a:endParaRPr lang="en-US" sz="1500" dirty="0"/>
           </a:p>
@@ -10432,7 +10432,7 @@
                 <a:ea typeface="Cambria" pitchFamily="34" charset="-122"/>
                 <a:cs typeface="Cambria" pitchFamily="34" charset="-120"/>
               </a:rPr>
-              <a:t>GTFS de Fortaleza cruzado com população, renda e empregos do IPEA</a:t>
+              <a:t>GTFS de Fortaleza cruzado com o Censo 2022 e com os empregos do IPEA</a:t>
             </a:r>
             <a:endParaRPr lang="en-US" sz="2800" dirty="0"/>
           </a:p>
@@ -10602,7 +10602,7 @@
                   <a:schemeClr val="tx1"/>
                 </a:solidFill>
               </a:rPr>
-              <a:t>IPEA – Acesso a Oportunidades: população e renda (Censo 2010), empregos formais (RAIS 2019) e acessibilidade por ônibus (2019)</a:t>
+              <a:t>IBGE – Censo 2022: população e renda do responsável por setor censitário</a:t>
             </a:r>
             <a:endParaRPr lang="en-US" sz="1400" dirty="0"/>
           </a:p>
@@ -10620,7 +10620,7 @@
                   <a:schemeClr val="tx1"/>
                 </a:solidFill>
               </a:rPr>
-              <a:t>Grade de hexágonos H3 de ~0,1 km²</a:t>
+              <a:t>IPEA – Acesso a Oportunidades: empregos formais (RAIS 2019) e acessibilidade por ônibus (2019), em hexágonos de ~0,1 km²</a:t>
             </a:r>
             <a:endParaRPr lang="en-US" sz="1400" dirty="0"/>
           </a:p>
@@ -10826,6 +10826,24 @@
                   <a:schemeClr val="tx1"/>
                 </a:solidFill>
               </a:rPr>
+              <a:t>Setores do Censo repartidos nos hexágonos pela área</a:t>
+            </a:r>
+            <a:endParaRPr lang="en-US" sz="1400" dirty="0"/>
+          </a:p>
+          <a:p>
+            <a:pPr marL="177800" indent="-177800">
+              <a:spcAft>
+                <a:spcPts val="800"/>
+              </a:spcAft>
+              <a:buSzPct val="100000"/>
+              <a:buChar char="•"/>
+            </a:pPr>
+            <a:r>
+              <a:rPr lang="en-US" sz="1400" dirty="0">
+                <a:solidFill>
+                  <a:schemeClr val="tx1"/>
+                </a:solidFill>
+              </a:rPr>
               <a:t>Resultados por quintil de renda</a:t>
             </a:r>
             <a:endParaRPr lang="en-US" sz="1400" dirty="0"/>
@@ -10996,7 +11014,25 @@
                   <a:schemeClr val="tx1"/>
                 </a:solidFill>
               </a:rPr>
-              <a:t>População de 2010; acessibilidade do IPEA calculada com a rede de 2019</a:t>
+              <a:t>Renda = rendimento médio do responsável, não per capita</a:t>
+            </a:r>
+            <a:endParaRPr lang="en-US" sz="1400" dirty="0"/>
+          </a:p>
+          <a:p>
+            <a:pPr marL="177800" indent="-177800">
+              <a:spcAft>
+                <a:spcPts val="800"/>
+              </a:spcAft>
+              <a:buSzPct val="100000"/>
+              <a:buChar char="•"/>
+            </a:pPr>
+            <a:r>
+              <a:rPr lang="en-US" sz="1400" dirty="0">
+                <a:solidFill>
+                  <a:schemeClr val="tx1"/>
+                </a:solidFill>
+              </a:rPr>
+              <a:t>Empregos e acessibilidade do IPEA são de 2019</a:t>
             </a:r>
             <a:endParaRPr lang="en-US" sz="1400" dirty="0"/>
           </a:p>
@@ -12402,7 +12438,7 @@
                 <a:ea typeface="Cambria" pitchFamily="34" charset="-122"/>
                 <a:cs typeface="Cambria" pitchFamily="34" charset="-120"/>
               </a:rPr>
-              <a:t>Quase todos moram perto de uma parada, mas 1 em cada 5 não tem ônibus frequente</a:t>
+              <a:t>Quase todos moram perto de uma parada, mas quase 1 em cada 4 não tem ônibus frequente</a:t>
             </a:r>
             <a:endParaRPr lang="en-US" sz="2800" dirty="0"/>
           </a:p>
@@ -12434,7 +12470,7 @@
       </p:pic>
       <p:sp>
         <p:nvSpPr>
-          <p:cNvPr id="5" name="Destaque 99,7%"/>
+          <p:cNvPr id="5" name="Destaque 99,3%"/>
           <p:cNvSpPr txBox="1"/>
           <p:nvPr/>
         </p:nvSpPr>
@@ -12465,7 +12501,7 @@
                 <a:ea typeface="Cambria" pitchFamily="34" charset="-122"/>
                 <a:cs typeface="Cambria" pitchFamily="34" charset="-120"/>
               </a:rPr>
-              <a:t>99,7%</a:t>
+              <a:t>99,3%</a:t>
             </a:r>
             <a:endParaRPr lang="en-US" sz="4000" dirty="0"/>
           </a:p>
@@ -12487,7 +12523,7 @@
       </p:sp>
       <p:sp>
         <p:nvSpPr>
-          <p:cNvPr id="6" name="Destaque 79,5%"/>
+          <p:cNvPr id="6" name="Destaque 76,8%"/>
           <p:cNvSpPr txBox="1"/>
           <p:nvPr/>
         </p:nvSpPr>
@@ -12518,7 +12554,7 @@
                 <a:ea typeface="Cambria" pitchFamily="34" charset="-122"/>
                 <a:cs typeface="Cambria" pitchFamily="34" charset="-120"/>
               </a:rPr>
-              <a:t>79,5%</a:t>
+              <a:t>76,8%</a:t>
             </a:r>
             <a:endParaRPr lang="en-US" sz="4000" dirty="0"/>
           </a:p>
@@ -12540,7 +12576,7 @@
       </p:sp>
       <p:sp>
         <p:nvSpPr>
-          <p:cNvPr id="7" name="Destaque ≈ 496 mil"/>
+          <p:cNvPr id="7" name="Destaque ≈ 561 mil"/>
           <p:cNvSpPr txBox="1"/>
           <p:nvPr/>
         </p:nvSpPr>
@@ -12571,7 +12607,7 @@
                 <a:ea typeface="Cambria" pitchFamily="34" charset="-122"/>
                 <a:cs typeface="Cambria" pitchFamily="34" charset="-120"/>
               </a:rPr>
-              <a:t>≈ 496 mil</a:t>
+              <a:t>≈ 561 mil</a:t>
             </a:r>
             <a:endParaRPr lang="en-US" sz="4000" dirty="0"/>
           </a:p>
@@ -12585,7 +12621,7 @@
                   <a:schemeClr val="tx1"/>
                 </a:solidFill>
               </a:rPr>
-              <a:t>pessoas só contam com ônibus pouco frequente</a:t>
+              <a:t>pessoas sem ônibus frequente perto de casa</a:t>
             </a:r>
             <a:endParaRPr lang="en-US" sz="4000" dirty="0"/>
           </a:p>
@@ -12621,7 +12657,7 @@
                   <a:schemeClr val="accent5"/>
                 </a:solidFill>
               </a:rPr>
-              <a:t>Fontes: GTFS de Fortaleza; IPEA – Acesso a Oportunidades (população do Censo 2010 em hexágonos H3). Área de 500 m em linha reta ao redor das paradas.</a:t>
+              <a:t>Fontes: GTFS de Fortaleza; IBGE – Censo 2022 (população por setor, repartida nos hexágonos H3 do IPEA pela área). Área de 500 m em linha reta ao redor das paradas.</a:t>
             </a:r>
             <a:endParaRPr lang="en-US" sz="1000" dirty="0"/>
           </a:p>
@@ -12818,7 +12854,7 @@
       </p:pic>
       <p:sp>
         <p:nvSpPr>
-          <p:cNvPr id="6" name="Destaque 2,5x"/>
+          <p:cNvPr id="6" name="Destaque 2,3x"/>
           <p:cNvSpPr txBox="1"/>
           <p:nvPr/>
         </p:nvSpPr>
@@ -12849,7 +12885,7 @@
                 <a:ea typeface="Cambria" pitchFamily="34" charset="-122"/>
                 <a:cs typeface="Cambria" pitchFamily="34" charset="-120"/>
               </a:rPr>
-              <a:t>2,5×</a:t>
+              <a:t>2,3×</a:t>
             </a:r>
             <a:endParaRPr lang="en-US" sz="3600" dirty="0"/>
           </a:p>
@@ -12899,7 +12935,7 @@
                   <a:schemeClr val="accent5"/>
                 </a:solidFill>
               </a:rPr>
-              <a:t>Fontes: GTFS de Fortaleza; IPEA – Acesso a Oportunidades (renda: Censo 2010; empregos: RAIS 2019; acessibilidade por ônibus no pico calculada pelo IPEA com o GTFS de 2019).</a:t>
+              <a:t>Fontes: GTFS de Fortaleza; IBGE – Censo 2022 (população e rendimento médio do responsável por setor); IPEA (empregos: RAIS 2019; acessibilidade no pico calculada com o GTFS de 2019).</a:t>
             </a:r>
             <a:endParaRPr lang="en-US" sz="1000" dirty="0"/>
           </a:p>

</xml_diff>